<commit_message>
fix order of logo
</commit_message>
<xml_diff>
--- a/pic/adoption_logos/adoption.pptx
+++ b/pic/adoption_logos/adoption.pptx
@@ -104,6 +104,11 @@
       </a:defRPr>
     </a:lvl9pPr>
   </p:defaultTextStyle>
+  <p:extLst>
+    <p:ext uri="{EFAFB233-063F-42B5-8137-9DF3F51BA10A}">
+      <p15:sldGuideLst xmlns:p15="http://schemas.microsoft.com/office/powerpoint/2012/main"/>
+    </p:ext>
+  </p:extLst>
 </p:presentation>
 </file>
 
@@ -3337,44 +3342,15 @@
         </p:nvPicPr>
         <p:blipFill>
           <a:blip r:embed="rId2"/>
+          <a:srcRect t="18495" b="25747"/>
           <a:stretch>
             <a:fillRect/>
           </a:stretch>
         </p:blipFill>
         <p:spPr>
           <a:xfrm>
-            <a:off x="5397414" y="509732"/>
-            <a:ext cx="1735715" cy="540000"/>
-          </a:xfrm>
-          <a:prstGeom prst="rect">
-            <a:avLst/>
-          </a:prstGeom>
-        </p:spPr>
-      </p:pic>
-      <p:pic>
-        <p:nvPicPr>
-          <p:cNvPr id="7" name="图片 6">
-            <a:extLst>
-              <a:ext uri="{FF2B5EF4-FFF2-40B4-BE49-F238E27FC236}">
-                <a16:creationId xmlns:a16="http://schemas.microsoft.com/office/drawing/2014/main" id="{C0F80977-A2D8-62DB-7DA9-8D1C935F8177}"/>
-              </a:ext>
-            </a:extLst>
-          </p:cNvPr>
-          <p:cNvPicPr>
-            <a:picLocks noChangeAspect="1"/>
-          </p:cNvPicPr>
-          <p:nvPr/>
-        </p:nvPicPr>
-        <p:blipFill>
-          <a:blip r:embed="rId3"/>
-          <a:stretch>
-            <a:fillRect/>
-          </a:stretch>
-        </p:blipFill>
-        <p:spPr>
-          <a:xfrm>
-            <a:off x="11112825" y="509732"/>
-            <a:ext cx="603530" cy="540000"/>
+            <a:off x="5627338" y="582995"/>
+            <a:ext cx="2697824" cy="468000"/>
           </a:xfrm>
           <a:prstGeom prst="rect">
             <a:avLst/>
@@ -3396,16 +3372,16 @@
           <p:nvPr/>
         </p:nvPicPr>
         <p:blipFill>
-          <a:blip r:embed="rId4"/>
-          <a:srcRect l="13158" t="35109" r="11841" b="37063"/>
+          <a:blip r:embed="rId3"/>
+          <a:srcRect l="13158" t="39941" r="11841" b="40740"/>
           <a:stretch>
             <a:fillRect/>
           </a:stretch>
         </p:blipFill>
         <p:spPr>
           <a:xfrm>
-            <a:off x="2487189" y="509732"/>
-            <a:ext cx="2844374" cy="540000"/>
+            <a:off x="2761381" y="658826"/>
+            <a:ext cx="2731298" cy="360000"/>
           </a:xfrm>
           <a:prstGeom prst="rect">
             <a:avLst/>
@@ -3418,6 +3394,36 @@
             <a:extLst>
               <a:ext uri="{FF2B5EF4-FFF2-40B4-BE49-F238E27FC236}">
                 <a16:creationId xmlns:a16="http://schemas.microsoft.com/office/drawing/2014/main" id="{62A720D6-E24D-C300-69B3-9BED8913545A}"/>
+              </a:ext>
+            </a:extLst>
+          </p:cNvPr>
+          <p:cNvPicPr>
+            <a:picLocks noChangeAspect="1"/>
+          </p:cNvPicPr>
+          <p:nvPr/>
+        </p:nvPicPr>
+        <p:blipFill>
+          <a:blip r:embed="rId4"/>
+          <a:stretch>
+            <a:fillRect/>
+          </a:stretch>
+        </p:blipFill>
+        <p:spPr>
+          <a:xfrm>
+            <a:off x="3720608" y="1365111"/>
+            <a:ext cx="1524774" cy="468000"/>
+          </a:xfrm>
+          <a:prstGeom prst="rect">
+            <a:avLst/>
+          </a:prstGeom>
+        </p:spPr>
+      </p:pic>
+      <p:pic>
+        <p:nvPicPr>
+          <p:cNvPr id="15" name="图片 14">
+            <a:extLst>
+              <a:ext uri="{FF2B5EF4-FFF2-40B4-BE49-F238E27FC236}">
+                <a16:creationId xmlns:a16="http://schemas.microsoft.com/office/drawing/2014/main" id="{13C43218-0962-6866-FA66-9214F47D211D}"/>
               </a:ext>
             </a:extLst>
           </p:cNvPr>
@@ -3434,38 +3440,8 @@
         </p:blipFill>
         <p:spPr>
           <a:xfrm>
-            <a:off x="9226446" y="509732"/>
-            <a:ext cx="1759355" cy="540000"/>
-          </a:xfrm>
-          <a:prstGeom prst="rect">
-            <a:avLst/>
-          </a:prstGeom>
-        </p:spPr>
-      </p:pic>
-      <p:pic>
-        <p:nvPicPr>
-          <p:cNvPr id="15" name="图片 14">
-            <a:extLst>
-              <a:ext uri="{FF2B5EF4-FFF2-40B4-BE49-F238E27FC236}">
-                <a16:creationId xmlns:a16="http://schemas.microsoft.com/office/drawing/2014/main" id="{13C43218-0962-6866-FA66-9214F47D211D}"/>
-              </a:ext>
-            </a:extLst>
-          </p:cNvPr>
-          <p:cNvPicPr>
-            <a:picLocks noChangeAspect="1"/>
-          </p:cNvPicPr>
-          <p:nvPr/>
-        </p:nvPicPr>
-        <p:blipFill>
-          <a:blip r:embed="rId6"/>
-          <a:stretch>
-            <a:fillRect/>
-          </a:stretch>
-        </p:blipFill>
-        <p:spPr>
-          <a:xfrm>
-            <a:off x="7241844" y="509732"/>
-            <a:ext cx="1871866" cy="540000"/>
+            <a:off x="8459821" y="614442"/>
+            <a:ext cx="1497493" cy="432000"/>
           </a:xfrm>
           <a:prstGeom prst="rect">
             <a:avLst/>
@@ -3487,15 +3463,47 @@
           <p:nvPr/>
         </p:nvPicPr>
         <p:blipFill>
-          <a:blip r:embed="rId7"/>
+          <a:blip r:embed="rId6"/>
+          <a:srcRect t="23986" b="19317"/>
           <a:stretch>
             <a:fillRect/>
           </a:stretch>
         </p:blipFill>
         <p:spPr>
           <a:xfrm>
-            <a:off x="337128" y="509732"/>
-            <a:ext cx="2084210" cy="540000"/>
+            <a:off x="204464" y="654995"/>
+            <a:ext cx="2450710" cy="360000"/>
+          </a:xfrm>
+          <a:prstGeom prst="rect">
+            <a:avLst/>
+          </a:prstGeom>
+        </p:spPr>
+      </p:pic>
+      <p:pic>
+        <p:nvPicPr>
+          <p:cNvPr id="3" name="图片 2">
+            <a:extLst>
+              <a:ext uri="{FF2B5EF4-FFF2-40B4-BE49-F238E27FC236}">
+                <a16:creationId xmlns:a16="http://schemas.microsoft.com/office/drawing/2014/main" id="{831790C4-D082-6E8F-5B7A-7A1A34264729}"/>
+              </a:ext>
+            </a:extLst>
+          </p:cNvPr>
+          <p:cNvPicPr>
+            <a:picLocks noChangeAspect="1"/>
+          </p:cNvPicPr>
+          <p:nvPr/>
+        </p:nvPicPr>
+        <p:blipFill>
+          <a:blip r:embed="rId7"/>
+          <a:srcRect l="11371" t="34670" r="12418" b="38022"/>
+          <a:stretch>
+            <a:fillRect/>
+          </a:stretch>
+        </p:blipFill>
+        <p:spPr>
+          <a:xfrm>
+            <a:off x="5627339" y="1365111"/>
+            <a:ext cx="1961345" cy="468000"/>
           </a:xfrm>
           <a:prstGeom prst="rect">
             <a:avLst/>

</xml_diff>

<commit_message>
update overview and add logo
</commit_message>
<xml_diff>
--- a/pic/adoption_logos/adoption.pptx
+++ b/pic/adoption_logos/adoption.pptx
@@ -259,7 +259,7 @@
           <a:p>
             <a:fld id="{8E119A9B-EC2C-F046-AB6F-3B9C9A28D3EB}" type="datetimeFigureOut">
               <a:rPr kumimoji="1" lang="zh-CN" altLang="en-US" smtClean="0"/>
-              <a:t>2026/3/20</a:t>
+              <a:t>2026/4/9</a:t>
             </a:fld>
             <a:endParaRPr kumimoji="1" lang="zh-CN" altLang="en-US"/>
           </a:p>
@@ -457,7 +457,7 @@
           <a:p>
             <a:fld id="{8E119A9B-EC2C-F046-AB6F-3B9C9A28D3EB}" type="datetimeFigureOut">
               <a:rPr kumimoji="1" lang="zh-CN" altLang="en-US" smtClean="0"/>
-              <a:t>2026/3/20</a:t>
+              <a:t>2026/4/9</a:t>
             </a:fld>
             <a:endParaRPr kumimoji="1" lang="zh-CN" altLang="en-US"/>
           </a:p>
@@ -665,7 +665,7 @@
           <a:p>
             <a:fld id="{8E119A9B-EC2C-F046-AB6F-3B9C9A28D3EB}" type="datetimeFigureOut">
               <a:rPr kumimoji="1" lang="zh-CN" altLang="en-US" smtClean="0"/>
-              <a:t>2026/3/20</a:t>
+              <a:t>2026/4/9</a:t>
             </a:fld>
             <a:endParaRPr kumimoji="1" lang="zh-CN" altLang="en-US"/>
           </a:p>
@@ -863,7 +863,7 @@
           <a:p>
             <a:fld id="{8E119A9B-EC2C-F046-AB6F-3B9C9A28D3EB}" type="datetimeFigureOut">
               <a:rPr kumimoji="1" lang="zh-CN" altLang="en-US" smtClean="0"/>
-              <a:t>2026/3/20</a:t>
+              <a:t>2026/4/9</a:t>
             </a:fld>
             <a:endParaRPr kumimoji="1" lang="zh-CN" altLang="en-US"/>
           </a:p>
@@ -1138,7 +1138,7 @@
           <a:p>
             <a:fld id="{8E119A9B-EC2C-F046-AB6F-3B9C9A28D3EB}" type="datetimeFigureOut">
               <a:rPr kumimoji="1" lang="zh-CN" altLang="en-US" smtClean="0"/>
-              <a:t>2026/3/20</a:t>
+              <a:t>2026/4/9</a:t>
             </a:fld>
             <a:endParaRPr kumimoji="1" lang="zh-CN" altLang="en-US"/>
           </a:p>
@@ -1403,7 +1403,7 @@
           <a:p>
             <a:fld id="{8E119A9B-EC2C-F046-AB6F-3B9C9A28D3EB}" type="datetimeFigureOut">
               <a:rPr kumimoji="1" lang="zh-CN" altLang="en-US" smtClean="0"/>
-              <a:t>2026/3/20</a:t>
+              <a:t>2026/4/9</a:t>
             </a:fld>
             <a:endParaRPr kumimoji="1" lang="zh-CN" altLang="en-US"/>
           </a:p>
@@ -1815,7 +1815,7 @@
           <a:p>
             <a:fld id="{8E119A9B-EC2C-F046-AB6F-3B9C9A28D3EB}" type="datetimeFigureOut">
               <a:rPr kumimoji="1" lang="zh-CN" altLang="en-US" smtClean="0"/>
-              <a:t>2026/3/20</a:t>
+              <a:t>2026/4/9</a:t>
             </a:fld>
             <a:endParaRPr kumimoji="1" lang="zh-CN" altLang="en-US"/>
           </a:p>
@@ -1956,7 +1956,7 @@
           <a:p>
             <a:fld id="{8E119A9B-EC2C-F046-AB6F-3B9C9A28D3EB}" type="datetimeFigureOut">
               <a:rPr kumimoji="1" lang="zh-CN" altLang="en-US" smtClean="0"/>
-              <a:t>2026/3/20</a:t>
+              <a:t>2026/4/9</a:t>
             </a:fld>
             <a:endParaRPr kumimoji="1" lang="zh-CN" altLang="en-US"/>
           </a:p>
@@ -2069,7 +2069,7 @@
           <a:p>
             <a:fld id="{8E119A9B-EC2C-F046-AB6F-3B9C9A28D3EB}" type="datetimeFigureOut">
               <a:rPr kumimoji="1" lang="zh-CN" altLang="en-US" smtClean="0"/>
-              <a:t>2026/3/20</a:t>
+              <a:t>2026/4/9</a:t>
             </a:fld>
             <a:endParaRPr kumimoji="1" lang="zh-CN" altLang="en-US"/>
           </a:p>
@@ -2380,7 +2380,7 @@
           <a:p>
             <a:fld id="{8E119A9B-EC2C-F046-AB6F-3B9C9A28D3EB}" type="datetimeFigureOut">
               <a:rPr kumimoji="1" lang="zh-CN" altLang="en-US" smtClean="0"/>
-              <a:t>2026/3/20</a:t>
+              <a:t>2026/4/9</a:t>
             </a:fld>
             <a:endParaRPr kumimoji="1" lang="zh-CN" altLang="en-US"/>
           </a:p>
@@ -2668,7 +2668,7 @@
           <a:p>
             <a:fld id="{8E119A9B-EC2C-F046-AB6F-3B9C9A28D3EB}" type="datetimeFigureOut">
               <a:rPr kumimoji="1" lang="zh-CN" altLang="en-US" smtClean="0"/>
-              <a:t>2026/3/20</a:t>
+              <a:t>2026/4/9</a:t>
             </a:fld>
             <a:endParaRPr kumimoji="1" lang="zh-CN" altLang="en-US"/>
           </a:p>
@@ -2909,7 +2909,7 @@
           <a:p>
             <a:fld id="{8E119A9B-EC2C-F046-AB6F-3B9C9A28D3EB}" type="datetimeFigureOut">
               <a:rPr kumimoji="1" lang="zh-CN" altLang="en-US" smtClean="0"/>
-              <a:t>2026/3/20</a:t>
+              <a:t>2026/4/9</a:t>
             </a:fld>
             <a:endParaRPr kumimoji="1" lang="zh-CN" altLang="en-US"/>
           </a:p>
@@ -3410,7 +3410,7 @@
         </p:blipFill>
         <p:spPr>
           <a:xfrm>
-            <a:off x="3720608" y="1365111"/>
+            <a:off x="324266" y="1365111"/>
             <a:ext cx="1524774" cy="468000"/>
           </a:xfrm>
           <a:prstGeom prst="rect">
@@ -3502,8 +3502,81 @@
         </p:blipFill>
         <p:spPr>
           <a:xfrm>
-            <a:off x="5627339" y="1365111"/>
+            <a:off x="2356325" y="1365111"/>
             <a:ext cx="1961345" cy="468000"/>
+          </a:xfrm>
+          <a:prstGeom prst="rect">
+            <a:avLst/>
+          </a:prstGeom>
+        </p:spPr>
+      </p:pic>
+      <p:pic>
+        <p:nvPicPr>
+          <p:cNvPr id="4" name="图形 3">
+            <a:extLst>
+              <a:ext uri="{FF2B5EF4-FFF2-40B4-BE49-F238E27FC236}">
+                <a16:creationId xmlns:a16="http://schemas.microsoft.com/office/drawing/2014/main" id="{84EE99EC-71FF-F3E3-348F-52E1D05CF987}"/>
+              </a:ext>
+            </a:extLst>
+          </p:cNvPr>
+          <p:cNvPicPr>
+            <a:picLocks noChangeAspect="1"/>
+          </p:cNvPicPr>
+          <p:nvPr/>
+        </p:nvPicPr>
+        <p:blipFill>
+          <a:blip>
+            <a:extLst>
+              <a:ext uri="{96DAC541-7B7A-43D3-8B79-37D633B846F1}">
+                <asvg:svgBlip xmlns:asvg="http://schemas.microsoft.com/office/drawing/2016/SVG/main" r:embed="rId8"/>
+              </a:ext>
+            </a:extLst>
+          </a:blip>
+          <a:srcRect l="10771" t="37311" r="10558" b="35966"/>
+          <a:stretch>
+            <a:fillRect/>
+          </a:stretch>
+        </p:blipFill>
+        <p:spPr>
+          <a:xfrm>
+            <a:off x="4824955" y="1365111"/>
+            <a:ext cx="2066676" cy="468000"/>
+          </a:xfrm>
+          <a:prstGeom prst="rect">
+            <a:avLst/>
+          </a:prstGeom>
+        </p:spPr>
+      </p:pic>
+      <p:pic>
+        <p:nvPicPr>
+          <p:cNvPr id="7" name="图形 6">
+            <a:extLst>
+              <a:ext uri="{FF2B5EF4-FFF2-40B4-BE49-F238E27FC236}">
+                <a16:creationId xmlns:a16="http://schemas.microsoft.com/office/drawing/2014/main" id="{4269FE35-C4B8-7154-6E5C-11728C946E1A}"/>
+              </a:ext>
+            </a:extLst>
+          </p:cNvPr>
+          <p:cNvPicPr>
+            <a:picLocks noChangeAspect="1"/>
+          </p:cNvPicPr>
+          <p:nvPr/>
+        </p:nvPicPr>
+        <p:blipFill>
+          <a:blip>
+            <a:extLst>
+              <a:ext uri="{96DAC541-7B7A-43D3-8B79-37D633B846F1}">
+                <asvg:svgBlip xmlns:asvg="http://schemas.microsoft.com/office/drawing/2016/SVG/main" r:embed="rId9"/>
+              </a:ext>
+            </a:extLst>
+          </a:blip>
+          <a:stretch>
+            <a:fillRect/>
+          </a:stretch>
+        </p:blipFill>
+        <p:spPr>
+          <a:xfrm>
+            <a:off x="7398915" y="1365111"/>
+            <a:ext cx="2558399" cy="468000"/>
           </a:xfrm>
           <a:prstGeom prst="rect">
             <a:avLst/>

</xml_diff>